<commit_message>
Update electricity awareness presentation
</commit_message>
<xml_diff>
--- a/Electricity_Consumption_Awareness_Agent_sujit.pptx
+++ b/Electricity_Consumption_Awareness_Agent_sujit.pptx
@@ -262,7 +262,7 @@
       <p15:sldGuideLst xmlns:p15="http://schemas.microsoft.com/office/powerpoint/2012/main"/>
     </p:ext>
     <p:ext uri="GoogleSlidesCustomDataVersion2">
-      <go:slidesCustomData xmlns:go="http://customooxmlschemas.google.com/" xmlns:ahyp="http://schemas.microsoft.com/office/drawing/2018/hyperlinkcolor" xmlns:p15="http://schemas.microsoft.com/office/powerpoint/2012/main" xmlns:p14="http://schemas.microsoft.com/office/powerpoint/2010/main" xmlns:com="http://schemas.openxmlformats.org/drawingml/2006/compatibility" xmlns:pvml="urn:schemas-microsoft-com:office:powerpoint" xmlns:v="urn:schemas-microsoft-com:vml" xmlns:o="urn:schemas-microsoft-com:office:office" xmlns:dgm="http://schemas.openxmlformats.org/drawingml/2006/diagram" xmlns:c="http://schemas.openxmlformats.org/drawingml/2006/chart" xmlns:mv="urn:schemas-microsoft-com:mac:vml" xmlns:mc="http://schemas.openxmlformats.org/markup-compatibility/2006" xmlns="" r:id="rId27" roundtripDataSignature="AMtx7mjt3491jQ7aCoyIz2WXeHKroE7tpQ=="/>
+      <go:slidesCustomData xmlns="" xmlns:mc="http://schemas.openxmlformats.org/markup-compatibility/2006" xmlns:mv="urn:schemas-microsoft-com:mac:vml" xmlns:c="http://schemas.openxmlformats.org/drawingml/2006/chart" xmlns:dgm="http://schemas.openxmlformats.org/drawingml/2006/diagram" xmlns:o="urn:schemas-microsoft-com:office:office" xmlns:v="urn:schemas-microsoft-com:vml" xmlns:pvml="urn:schemas-microsoft-com:office:powerpoint" xmlns:com="http://schemas.openxmlformats.org/drawingml/2006/compatibility" xmlns:p14="http://schemas.microsoft.com/office/powerpoint/2010/main" xmlns:p15="http://schemas.microsoft.com/office/powerpoint/2012/main" xmlns:ahyp="http://schemas.microsoft.com/office/drawing/2018/hyperlinkcolor" xmlns:go="http://customooxmlschemas.google.com/" r:id="rId27" roundtripDataSignature="AMtx7mjt3491jQ7aCoyIz2WXeHKroE7tpQ=="/>
     </p:ext>
   </p:extLst>
 </p:presentation>
@@ -12845,8 +12845,8 @@
         </p:blipFill>
         <p:spPr>
           <a:xfrm>
-            <a:off x="3893573" y="3578942"/>
-            <a:ext cx="1533833" cy="1188501"/>
+            <a:off x="3893573" y="3549446"/>
+            <a:ext cx="1533833" cy="1217998"/>
           </a:xfrm>
           <a:prstGeom prst="rect">
             <a:avLst/>
@@ -14559,13 +14559,13 @@
               <a:t>GitHub URL: </a:t>
             </a:r>
             <a:r>
-              <a:rPr lang="en-US" sz="1600" b="0" dirty="0">
+              <a:rPr lang="en-IN" sz="1600" dirty="0">
                 <a:solidFill>
                   <a:srgbClr val="182B3A"/>
                 </a:solidFill>
-                <a:latin typeface="Arial"/>
+                <a:hlinkClick r:id="rId3"/>
               </a:rPr>
-              <a:t> </a:t>
+              <a:t>https://github.com/devsujit77/powerwise.git</a:t>
             </a:r>
             <a:r>
               <a:rPr lang="en-IN" sz="1600" dirty="0">
@@ -14573,7 +14573,7 @@
                   <a:srgbClr val="182B3A"/>
                 </a:solidFill>
               </a:rPr>
-              <a:t>https://github.com/devsujit77</a:t>
+              <a:t> </a:t>
             </a:r>
             <a:endParaRPr sz="1600" b="0" dirty="0">
               <a:solidFill>
@@ -17237,13 +17237,13 @@
               <a:buSzPts val="3500"/>
             </a:pPr>
             <a:r>
-              <a:rPr sz="2700" b="1">
+              <a:rPr sz="2700" b="1" dirty="0">
                 <a:solidFill>
                   <a:srgbClr val="071B2B"/>
                 </a:solidFill>
                 <a:latin typeface="Arial"/>
               </a:rPr>
-              <a:t>Knowledge Sources – Electricity Awareness</a:t>
+              <a:t> Electricity Awareness</a:t>
             </a:r>
             <a:endParaRPr sz="2400" b="1" dirty="0">
               <a:sym typeface="Times New Roman"/>
@@ -17251,36 +17251,6 @@
           </a:p>
         </p:txBody>
       </p:sp>
-      <p:pic>
-        <p:nvPicPr>
-          <p:cNvPr id="6" name="Picture 5" descr="A screenshot of a computer&#10;&#10;AI-generated content may be incorrect.">
-            <a:extLst>
-              <a:ext uri="{FF2B5EF4-FFF2-40B4-BE49-F238E27FC236}">
-                <a16:creationId xmlns:a16="http://schemas.microsoft.com/office/drawing/2014/main" id="{A0D6461E-DA88-AFE8-EAFF-84E9A424BF26}"/>
-              </a:ext>
-            </a:extLst>
-          </p:cNvPr>
-          <p:cNvPicPr>
-            <a:picLocks noChangeAspect="1"/>
-          </p:cNvPicPr>
-          <p:nvPr/>
-        </p:nvPicPr>
-        <p:blipFill>
-          <a:blip r:embed="rId3"/>
-          <a:stretch>
-            <a:fillRect/>
-          </a:stretch>
-        </p:blipFill>
-        <p:spPr>
-          <a:xfrm>
-            <a:off x="213276" y="984647"/>
-            <a:ext cx="11539779" cy="5489305"/>
-          </a:xfrm>
-          <a:prstGeom prst="rect">
-            <a:avLst/>
-          </a:prstGeom>
-        </p:spPr>
-      </p:pic>
       <p:sp>
         <p:nvSpPr>
           <p:cNvPr id="18" name="TextBox 17"/>
@@ -17316,6 +17286,36 @@
           </a:p>
         </p:txBody>
       </p:sp>
+      <p:pic>
+        <p:nvPicPr>
+          <p:cNvPr id="5" name="Picture 4">
+            <a:extLst>
+              <a:ext uri="{FF2B5EF4-FFF2-40B4-BE49-F238E27FC236}">
+                <a16:creationId xmlns:a16="http://schemas.microsoft.com/office/drawing/2014/main" id="{4A1C03D8-55F7-5603-7A35-27A8A034C121}"/>
+              </a:ext>
+            </a:extLst>
+          </p:cNvPr>
+          <p:cNvPicPr>
+            <a:picLocks noChangeAspect="1"/>
+          </p:cNvPicPr>
+          <p:nvPr/>
+        </p:nvPicPr>
+        <p:blipFill>
+          <a:blip r:embed="rId3"/>
+          <a:stretch>
+            <a:fillRect/>
+          </a:stretch>
+        </p:blipFill>
+        <p:spPr>
+          <a:xfrm>
+            <a:off x="996078" y="1317523"/>
+            <a:ext cx="10199843" cy="4817806"/>
+          </a:xfrm>
+          <a:prstGeom prst="rect">
+            <a:avLst/>
+          </a:prstGeom>
+        </p:spPr>
+      </p:pic>
     </p:spTree>
     <p:extLst>
       <p:ext uri="{BB962C8B-B14F-4D97-AF65-F5344CB8AC3E}">
@@ -17384,92 +17384,36 @@
           <a:lstStyle/>
           <a:p>
             <a:r>
-              <a:rPr sz="2700" b="1">
+              <a:rPr sz="2700" b="1" dirty="0">
                 <a:solidFill>
                   <a:srgbClr val="071B2B"/>
                 </a:solidFill>
                 <a:latin typeface="Arial"/>
               </a:rPr>
-              <a:t>Prompt with Output – PowerWise</a:t>
+              <a:t> Output – </a:t>
             </a:r>
-            <a:endParaRPr lang="en-US"/>
+            <a:r>
+              <a:rPr sz="2700" b="1" dirty="0" err="1">
+                <a:solidFill>
+                  <a:srgbClr val="071B2B"/>
+                </a:solidFill>
+                <a:latin typeface="Arial"/>
+              </a:rPr>
+              <a:t>PowerWise</a:t>
+            </a:r>
+            <a:r>
+              <a:rPr lang="en-US" sz="2700" b="1" dirty="0">
+                <a:solidFill>
+                  <a:srgbClr val="071B2B"/>
+                </a:solidFill>
+                <a:latin typeface="Arial"/>
+              </a:rPr>
+              <a:t> AI Chatbot</a:t>
+            </a:r>
+            <a:endParaRPr lang="en-US" dirty="0"/>
           </a:p>
         </p:txBody>
       </p:sp>
-      <p:sp>
-        <p:nvSpPr>
-          <p:cNvPr id="4" name="TextBox 3">
-            <a:extLst>
-              <a:ext uri="{FF2B5EF4-FFF2-40B4-BE49-F238E27FC236}">
-                <a16:creationId xmlns:a16="http://schemas.microsoft.com/office/drawing/2014/main" id="{878DC055-9DE8-731B-4573-E65371EBEDCA}"/>
-              </a:ext>
-            </a:extLst>
-          </p:cNvPr>
-          <p:cNvSpPr txBox="1"/>
-          <p:nvPr/>
-        </p:nvSpPr>
-        <p:spPr>
-          <a:xfrm>
-            <a:off x="1375037" y="1172400"/>
-            <a:ext cx="8491957" cy="400110"/>
-          </a:xfrm>
-          <a:prstGeom prst="rect">
-            <a:avLst/>
-          </a:prstGeom>
-          <a:noFill/>
-        </p:spPr>
-        <p:txBody>
-          <a:bodyPr rot="0" spcFirstLastPara="0" vertOverflow="overflow" horzOverflow="overflow" vert="horz" wrap="square" lIns="91440" tIns="45720" rIns="91440" bIns="45720" numCol="1" spcCol="0" rtlCol="0" fromWordArt="0" anchor="t" anchorCtr="0" forceAA="0" compatLnSpc="1">
-            <a:prstTxWarp prst="textNoShape">
-              <a:avLst/>
-            </a:prstTxWarp>
-            <a:spAutoFit/>
-          </a:bodyPr>
-          <a:lstStyle/>
-          <a:p>
-            <a:r>
-              <a:rPr sz="1400" b="0">
-                <a:solidFill>
-                  <a:srgbClr val="607386"/>
-                </a:solidFill>
-                <a:latin typeface="Arial"/>
-              </a:rPr>
-              <a:t>Example test conversation demonstrating consumption analysis.</a:t>
-            </a:r>
-            <a:endParaRPr lang="en-US"/>
-          </a:p>
-        </p:txBody>
-      </p:sp>
-      <p:pic>
-        <p:nvPicPr>
-          <p:cNvPr id="5" name="Picture 4" descr="A screenshot of a computer&#10;&#10;AI-generated content may be incorrect.">
-            <a:extLst>
-              <a:ext uri="{FF2B5EF4-FFF2-40B4-BE49-F238E27FC236}">
-                <a16:creationId xmlns:a16="http://schemas.microsoft.com/office/drawing/2014/main" id="{6EA8F3D0-52BA-100E-3FD8-228494F48350}"/>
-              </a:ext>
-            </a:extLst>
-          </p:cNvPr>
-          <p:cNvPicPr>
-            <a:picLocks noChangeAspect="1"/>
-          </p:cNvPicPr>
-          <p:nvPr/>
-        </p:nvPicPr>
-        <p:blipFill>
-          <a:blip r:embed="rId3"/>
-          <a:stretch>
-            <a:fillRect/>
-          </a:stretch>
-        </p:blipFill>
-        <p:spPr>
-          <a:xfrm>
-            <a:off x="489054" y="1154932"/>
-            <a:ext cx="9628931" cy="4962404"/>
-          </a:xfrm>
-          <a:prstGeom prst="rect">
-            <a:avLst/>
-          </a:prstGeom>
-        </p:spPr>
-      </p:pic>
       <p:sp>
         <p:nvSpPr>
           <p:cNvPr id="8" name="TextBox 7"/>
@@ -17505,6 +17449,36 @@
           </a:p>
         </p:txBody>
       </p:sp>
+      <p:pic>
+        <p:nvPicPr>
+          <p:cNvPr id="11" name="Picture 10">
+            <a:extLst>
+              <a:ext uri="{FF2B5EF4-FFF2-40B4-BE49-F238E27FC236}">
+                <a16:creationId xmlns:a16="http://schemas.microsoft.com/office/drawing/2014/main" id="{A925392B-C3B9-445D-F46F-39AB19A57CEF}"/>
+              </a:ext>
+            </a:extLst>
+          </p:cNvPr>
+          <p:cNvPicPr>
+            <a:picLocks noChangeAspect="1"/>
+          </p:cNvPicPr>
+          <p:nvPr/>
+        </p:nvPicPr>
+        <p:blipFill>
+          <a:blip r:embed="rId3"/>
+          <a:stretch>
+            <a:fillRect/>
+          </a:stretch>
+        </p:blipFill>
+        <p:spPr>
+          <a:xfrm>
+            <a:off x="914400" y="1020899"/>
+            <a:ext cx="10579510" cy="4986611"/>
+          </a:xfrm>
+          <a:prstGeom prst="rect">
+            <a:avLst/>
+          </a:prstGeom>
+        </p:spPr>
+      </p:pic>
     </p:spTree>
     <p:extLst>
       <p:ext uri="{BB962C8B-B14F-4D97-AF65-F5344CB8AC3E}">

</xml_diff>